<commit_message>
feat: update SIH presentation deck with rich typography, large font sizes, complete card content, and exact slide 1 metadata
</commit_message>
<xml_diff>
--- a/docs/SentinelAI_SIH_Presentation.pptx
+++ b/docs/SentinelAI_SIH_Presentation.pptx
@@ -3109,8 +3109,8 @@
         </p:nvSpPr>
         <p:spPr>
           <a:xfrm>
-            <a:off x="731520" y="731520"/>
-            <a:ext cx="10728655" cy="5394960"/>
+            <a:off x="731520" y="548640"/>
+            <a:ext cx="10728655" cy="5760720"/>
           </a:xfrm>
           <a:prstGeom prst="roundRect">
             <a:avLst/>
@@ -3118,7 +3118,7 @@
           <a:solidFill>
             <a:srgbClr val="F8FAFC"/>
           </a:solidFill>
-          <a:ln w="25400">
+          <a:ln w="31750">
             <a:solidFill>
               <a:srgbClr val="0284C7"/>
             </a:solidFill>
@@ -3154,8 +3154,8 @@
         </p:nvSpPr>
         <p:spPr>
           <a:xfrm>
-            <a:off x="1097280" y="1005840"/>
-            <a:ext cx="9966960" cy="4846320"/>
+            <a:off x="1097280" y="822960"/>
+            <a:ext cx="9997135" cy="5212080"/>
           </a:xfrm>
           <a:prstGeom prst="rect">
             <a:avLst/>
@@ -3169,7 +3169,7 @@
           <a:lstStyle/>
           <a:p>
             <a:pPr>
-              <a:defRPr sz="1200" b="1">
+              <a:defRPr sz="1300" b="1">
                 <a:solidFill>
                   <a:srgbClr val="0284C7"/>
                 </a:solidFill>
@@ -3185,9 +3185,9 @@
                 <a:spcPts val="800"/>
               </a:spcBef>
               <a:spcAft>
-                <a:spcPts val="1800"/>
+                <a:spcPts val="2400"/>
               </a:spcAft>
-              <a:defRPr sz="2400" b="1">
+              <a:defRPr sz="2600" b="1">
                 <a:solidFill>
                   <a:srgbClr val="0F172A"/>
                 </a:solidFill>
@@ -3200,11 +3200,11 @@
           <a:p>
             <a:pPr>
               <a:spcAft>
-                <a:spcPts val="600"/>
+                <a:spcPts val="1000"/>
               </a:spcAft>
             </a:pPr>
             <a:r>
-              <a:rPr b="1" sz="1200">
+              <a:rPr b="1" sz="1400">
                 <a:solidFill>
                   <a:srgbClr val="D97706"/>
                 </a:solidFill>
@@ -3212,22 +3212,22 @@
               <a:t>Problem Statement ID:      </a:t>
             </a:r>
             <a:r>
-              <a:rPr sz="1200">
+              <a:rPr b="1" sz="1400">
                 <a:solidFill>
                   <a:srgbClr val="1E293B"/>
                 </a:solidFill>
               </a:rPr>
-              <a:t>SIH-2026-CYBER-001</a:t>
+              <a:t>Task 4</a:t>
             </a:r>
           </a:p>
           <a:p>
             <a:pPr>
               <a:spcAft>
-                <a:spcPts val="600"/>
+                <a:spcPts val="1000"/>
               </a:spcAft>
             </a:pPr>
             <a:r>
-              <a:rPr b="1" sz="1200">
+              <a:rPr b="1" sz="1400">
                 <a:solidFill>
                   <a:srgbClr val="D97706"/>
                 </a:solidFill>
@@ -3235,7 +3235,7 @@
               <a:t>Problem Statement Title:   </a:t>
             </a:r>
             <a:r>
-              <a:rPr sz="1200">
+              <a:rPr b="1" sz="1400">
                 <a:solidFill>
                   <a:srgbClr val="1E293B"/>
                 </a:solidFill>
@@ -3246,11 +3246,11 @@
           <a:p>
             <a:pPr>
               <a:spcAft>
-                <a:spcPts val="600"/>
+                <a:spcPts val="1000"/>
               </a:spcAft>
             </a:pPr>
             <a:r>
-              <a:rPr b="1" sz="1200">
+              <a:rPr b="1" sz="1400">
                 <a:solidFill>
                   <a:srgbClr val="D97706"/>
                 </a:solidFill>
@@ -3258,7 +3258,7 @@
               <a:t>Theme:                     </a:t>
             </a:r>
             <a:r>
-              <a:rPr sz="1200">
+              <a:rPr b="1" sz="1400">
                 <a:solidFill>
                   <a:srgbClr val="1E293B"/>
                 </a:solidFill>
@@ -3269,11 +3269,11 @@
           <a:p>
             <a:pPr>
               <a:spcAft>
-                <a:spcPts val="600"/>
+                <a:spcPts val="1000"/>
               </a:spcAft>
             </a:pPr>
             <a:r>
-              <a:rPr b="1" sz="1200">
+              <a:rPr b="1" sz="1400">
                 <a:solidFill>
                   <a:srgbClr val="D97706"/>
                 </a:solidFill>
@@ -3281,7 +3281,7 @@
               <a:t>PS Category:               </a:t>
             </a:r>
             <a:r>
-              <a:rPr sz="1200">
+              <a:rPr b="1" sz="1400">
                 <a:solidFill>
                   <a:srgbClr val="1E293B"/>
                 </a:solidFill>
@@ -3292,11 +3292,11 @@
           <a:p>
             <a:pPr>
               <a:spcAft>
-                <a:spcPts val="600"/>
+                <a:spcPts val="1000"/>
               </a:spcAft>
             </a:pPr>
             <a:r>
-              <a:rPr b="1" sz="1200">
+              <a:rPr b="1" sz="1400">
                 <a:solidFill>
                   <a:srgbClr val="D97706"/>
                 </a:solidFill>
@@ -3304,22 +3304,22 @@
               <a:t>Team Name / Lead:          </a:t>
             </a:r>
             <a:r>
-              <a:rPr sz="1200">
+              <a:rPr b="1" sz="1400">
                 <a:solidFill>
                   <a:srgbClr val="1E293B"/>
                 </a:solidFill>
               </a:rPr>
-              <a:t>SentinelAI Team // Honeywell Cyber Security Operations Center</a:t>
+              <a:t>Raj Verma</a:t>
             </a:r>
           </a:p>
           <a:p>
             <a:pPr>
               <a:spcAft>
-                <a:spcPts val="600"/>
+                <a:spcPts val="1000"/>
               </a:spcAft>
             </a:pPr>
             <a:r>
-              <a:rPr b="1" sz="1200">
+              <a:rPr b="1" sz="1400">
                 <a:solidFill>
                   <a:srgbClr val="D97706"/>
                 </a:solidFill>
@@ -3327,12 +3327,12 @@
               <a:t>Registration ID:           </a:t>
             </a:r>
             <a:r>
-              <a:rPr sz="1200">
+              <a:rPr b="1" sz="1400">
                 <a:solidFill>
                   <a:srgbClr val="1E293B"/>
                 </a:solidFill>
               </a:rPr>
-              <a:t>SIH-REG-2026-9921</a:t>
+              <a:t>23BAI10806</a:t>
             </a:r>
           </a:p>
         </p:txBody>
@@ -3371,7 +3371,7 @@
         </p:nvSpPr>
         <p:spPr>
           <a:xfrm>
-            <a:off x="731520" y="365760"/>
+            <a:off x="731520" y="320040"/>
             <a:ext cx="10728655" cy="822960"/>
           </a:xfrm>
           <a:prstGeom prst="rect">
@@ -3386,7 +3386,7 @@
           <a:lstStyle/>
           <a:p>
             <a:pPr>
-              <a:defRPr sz="1100" b="1">
+              <a:defRPr sz="1200" b="1">
                 <a:solidFill>
                   <a:srgbClr val="0284C7"/>
                 </a:solidFill>
@@ -3399,7 +3399,7 @@
           </a:p>
           <a:p>
             <a:pPr>
-              <a:defRPr sz="2200" b="1">
+              <a:defRPr sz="2400" b="1">
                 <a:solidFill>
                   <a:srgbClr val="0F172A"/>
                 </a:solidFill>
@@ -3420,8 +3420,8 @@
         </p:nvSpPr>
         <p:spPr>
           <a:xfrm>
-            <a:off x="731520" y="1280160"/>
-            <a:ext cx="3413455" cy="5029200"/>
+            <a:off x="731520" y="1325880"/>
+            <a:ext cx="3413455" cy="5120640"/>
           </a:xfrm>
           <a:prstGeom prst="roundRect">
             <a:avLst/>
@@ -3429,7 +3429,7 @@
           <a:solidFill>
             <a:srgbClr val="F8FAFC"/>
           </a:solidFill>
-          <a:ln w="19050">
+          <a:ln w="25400">
             <a:solidFill>
               <a:srgbClr val="0284C7"/>
             </a:solidFill>
@@ -3465,8 +3465,8 @@
         </p:nvSpPr>
         <p:spPr>
           <a:xfrm>
-            <a:off x="731520" y="1280160"/>
-            <a:ext cx="3413455" cy="640080"/>
+            <a:off x="731520" y="1325880"/>
+            <a:ext cx="3413455" cy="685800"/>
           </a:xfrm>
           <a:prstGeom prst="roundRect">
             <a:avLst/>
@@ -3508,8 +3508,8 @@
         </p:nvSpPr>
         <p:spPr>
           <a:xfrm>
-            <a:off x="822960" y="1325880"/>
-            <a:ext cx="3230575" cy="548640"/>
+            <a:off x="822960" y="1371600"/>
+            <a:ext cx="3230575" cy="594360"/>
           </a:xfrm>
           <a:prstGeom prst="rect">
             <a:avLst/>
@@ -3523,7 +3523,7 @@
           <a:lstStyle/>
           <a:p>
             <a:pPr algn="ctr">
-              <a:defRPr sz="1300" b="1">
+              <a:defRPr sz="1400" b="1">
                 <a:solidFill>
                   <a:srgbClr val="FFFFFF"/>
                 </a:solidFill>
@@ -3543,8 +3543,8 @@
         </p:nvSpPr>
         <p:spPr>
           <a:xfrm>
-            <a:off x="914400" y="2011680"/>
-            <a:ext cx="3047695" cy="4114800"/>
+            <a:off x="914400" y="2103120"/>
+            <a:ext cx="3047695" cy="4206240"/>
           </a:xfrm>
           <a:prstGeom prst="rect">
             <a:avLst/>
@@ -3559,11 +3559,11 @@
           <a:p>
             <a:pPr>
               <a:spcAft>
-                <a:spcPts val="1200"/>
+                <a:spcPts val="1000"/>
               </a:spcAft>
             </a:pPr>
             <a:r>
-              <a:rPr b="1" sz="1100">
+              <a:rPr b="1" sz="1150">
                 <a:solidFill>
                   <a:srgbClr val="0F172A"/>
                 </a:solidFill>
@@ -3571,7 +3571,7 @@
               <a:t>• Core Architecture: </a:t>
             </a:r>
             <a:r>
-              <a:rPr sz="1050">
+              <a:rPr sz="1100">
                 <a:solidFill>
                   <a:srgbClr val="475569"/>
                 </a:solidFill>
@@ -3582,11 +3582,11 @@
           <a:p>
             <a:pPr>
               <a:spcAft>
-                <a:spcPts val="1200"/>
+                <a:spcPts val="1000"/>
               </a:spcAft>
             </a:pPr>
             <a:r>
-              <a:rPr b="1" sz="1100">
+              <a:rPr b="1" sz="1150">
                 <a:solidFill>
                   <a:srgbClr val="0F172A"/>
                 </a:solidFill>
@@ -3594,7 +3594,7 @@
               <a:t>• Dual-Engine Logic: </a:t>
             </a:r>
             <a:r>
-              <a:rPr sz="1050">
+              <a:rPr sz="1100">
                 <a:solidFill>
                   <a:srgbClr val="475569"/>
                 </a:solidFill>
@@ -3605,11 +3605,11 @@
           <a:p>
             <a:pPr>
               <a:spcAft>
-                <a:spcPts val="1200"/>
+                <a:spcPts val="1000"/>
               </a:spcAft>
             </a:pPr>
             <a:r>
-              <a:rPr b="1" sz="1100">
+              <a:rPr b="1" sz="1150">
                 <a:solidFill>
                   <a:srgbClr val="0F172A"/>
                 </a:solidFill>
@@ -3617,12 +3617,35 @@
               <a:t>• SOC Command Center: </a:t>
             </a:r>
             <a:r>
-              <a:rPr sz="1050">
+              <a:rPr sz="1100">
                 <a:solidFill>
                   <a:srgbClr val="475569"/>
                 </a:solidFill>
               </a:rPr>
               <a:t>Interactive glassmorphic dashboard featuring live Chart.js analytics, automated incident narratives, and XAI feature attribution.</a:t>
+            </a:r>
+          </a:p>
+          <a:p>
+            <a:pPr>
+              <a:spcAft>
+                <a:spcPts val="1000"/>
+              </a:spcAft>
+            </a:pPr>
+            <a:r>
+              <a:rPr b="1" sz="1150">
+                <a:solidFill>
+                  <a:srgbClr val="0F172A"/>
+                </a:solidFill>
+              </a:rPr>
+              <a:t>• Production Integration: </a:t>
+            </a:r>
+            <a:r>
+              <a:rPr sz="1100">
+                <a:solidFill>
+                  <a:srgbClr val="475569"/>
+                </a:solidFill>
+              </a:rPr>
+              <a:t>Real-time streaming ingestion pipeline designed for Kafka/Flink enterprise SIEM integration.</a:t>
             </a:r>
           </a:p>
         </p:txBody>
@@ -3635,8 +3658,8 @@
         </p:nvSpPr>
         <p:spPr>
           <a:xfrm>
-            <a:off x="4389120" y="1280160"/>
-            <a:ext cx="3413455" cy="5029200"/>
+            <a:off x="4389120" y="1325880"/>
+            <a:ext cx="3413455" cy="5120640"/>
           </a:xfrm>
           <a:prstGeom prst="roundRect">
             <a:avLst/>
@@ -3644,7 +3667,7 @@
           <a:solidFill>
             <a:srgbClr val="F8FAFC"/>
           </a:solidFill>
-          <a:ln w="19050">
+          <a:ln w="25400">
             <a:solidFill>
               <a:srgbClr val="D97706"/>
             </a:solidFill>
@@ -3680,8 +3703,8 @@
         </p:nvSpPr>
         <p:spPr>
           <a:xfrm>
-            <a:off x="4389120" y="1280160"/>
-            <a:ext cx="3413455" cy="640080"/>
+            <a:off x="4389120" y="1325880"/>
+            <a:ext cx="3413455" cy="685800"/>
           </a:xfrm>
           <a:prstGeom prst="roundRect">
             <a:avLst/>
@@ -3723,8 +3746,8 @@
         </p:nvSpPr>
         <p:spPr>
           <a:xfrm>
-            <a:off x="4480560" y="1325880"/>
-            <a:ext cx="3230575" cy="548640"/>
+            <a:off x="4480560" y="1371600"/>
+            <a:ext cx="3230575" cy="594360"/>
           </a:xfrm>
           <a:prstGeom prst="rect">
             <a:avLst/>
@@ -3738,7 +3761,7 @@
           <a:lstStyle/>
           <a:p>
             <a:pPr algn="ctr">
-              <a:defRPr sz="1300" b="1">
+              <a:defRPr sz="1400" b="1">
                 <a:solidFill>
                   <a:srgbClr val="FFFFFF"/>
                 </a:solidFill>
@@ -3758,8 +3781,8 @@
         </p:nvSpPr>
         <p:spPr>
           <a:xfrm>
-            <a:off x="4572000" y="2011680"/>
-            <a:ext cx="3047695" cy="4114800"/>
+            <a:off x="4572000" y="2103120"/>
+            <a:ext cx="3047695" cy="4206240"/>
           </a:xfrm>
           <a:prstGeom prst="rect">
             <a:avLst/>
@@ -3774,11 +3797,11 @@
           <a:p>
             <a:pPr>
               <a:spcAft>
-                <a:spcPts val="1200"/>
+                <a:spcPts val="1000"/>
               </a:spcAft>
             </a:pPr>
             <a:r>
-              <a:rPr b="1" sz="1100">
+              <a:rPr b="1" sz="1150">
                 <a:solidFill>
                   <a:srgbClr val="0F172A"/>
                 </a:solidFill>
@@ -3786,45 +3809,45 @@
               <a:t>• Operational Bottleneck: </a:t>
             </a:r>
             <a:r>
-              <a:rPr sz="1050">
+              <a:rPr sz="1100">
                 <a:solidFill>
                   <a:srgbClr val="475569"/>
                 </a:solidFill>
               </a:rPr>
-              <a:t>Unsupervised ML noise tails displace high-precision static rules at tight SOC alert budgets (Top 1%).</a:t>
+              <a:t>Unsupervised ML noise tails displace high-precision static rules at tight SOC alert budgets (Top 1% cutoffs).</a:t>
             </a:r>
           </a:p>
           <a:p>
             <a:pPr>
               <a:spcAft>
-                <a:spcPts val="1200"/>
+                <a:spcPts val="1000"/>
               </a:spcAft>
             </a:pPr>
             <a:r>
-              <a:rPr b="1" sz="1100">
+              <a:rPr b="1" sz="1150">
                 <a:solidFill>
                   <a:srgbClr val="0F172A"/>
                 </a:solidFill>
               </a:rPr>
-              <a:t>• Zero Rule Displacement: </a:t>
-            </a:r>
-            <a:r>
-              <a:rPr sz="1050">
+              <a:t>• Zero Rule Degradation: </a:t>
+            </a:r>
+            <a:r>
+              <a:rPr sz="1100">
                 <a:solidFill>
                   <a:srgbClr val="475569"/>
                 </a:solidFill>
               </a:rPr>
-              <a:t>Monotonic blend guarantees static rule floor is preserved intact, preventing high-precision catches from being crowded out.</a:t>
+              <a:t>Monotonic additive blend preserves baseline rule floor intact, preventing high-precision policy catches from being crowded out.</a:t>
             </a:r>
           </a:p>
           <a:p>
             <a:pPr>
               <a:spcAft>
-                <a:spcPts val="1200"/>
+                <a:spcPts val="1000"/>
               </a:spcAft>
             </a:pPr>
             <a:r>
-              <a:rPr b="1" sz="1100">
+              <a:rPr b="1" sz="1150">
                 <a:solidFill>
                   <a:srgbClr val="0F172A"/>
                 </a:solidFill>
@@ -3832,12 +3855,35 @@
               <a:t>• Analyst Queue Control: </a:t>
             </a:r>
             <a:r>
-              <a:rPr sz="1050">
+              <a:rPr sz="1100">
                 <a:solidFill>
                   <a:srgbClr val="475569"/>
                 </a:solidFill>
               </a:rPr>
-              <a:t>Eliminates SOC alert fatigue by maintaining high precision while enabling deep sequence threat hunting.</a:t>
+              <a:t>Restricts daily analyst workload to ~12 alerts/day while maintaining an 81.32% overall core attack catch rate.</a:t>
+            </a:r>
+          </a:p>
+          <a:p>
+            <a:pPr>
+              <a:spcAft>
+                <a:spcPts val="1000"/>
+              </a:spcAft>
+            </a:pPr>
+            <a:r>
+              <a:rPr b="1" sz="1150">
+                <a:solidFill>
+                  <a:srgbClr val="0F172A"/>
+                </a:solidFill>
+              </a:rPr>
+              <a:t>• STEALTH Threat Capture: </a:t>
+            </a:r>
+            <a:r>
+              <a:rPr sz="1100">
+                <a:solidFill>
+                  <a:srgbClr val="475569"/>
+                </a:solidFill>
+              </a:rPr>
+              <a:t>Surfaces multi-step lateral movement attacks that bypass traditional single-event static rules.</a:t>
             </a:r>
           </a:p>
         </p:txBody>
@@ -3850,8 +3896,8 @@
         </p:nvSpPr>
         <p:spPr>
           <a:xfrm>
-            <a:off x="8046720" y="1280160"/>
-            <a:ext cx="3413455" cy="5029200"/>
+            <a:off x="8046720" y="1325880"/>
+            <a:ext cx="3413455" cy="5120640"/>
           </a:xfrm>
           <a:prstGeom prst="roundRect">
             <a:avLst/>
@@ -3859,7 +3905,7 @@
           <a:solidFill>
             <a:srgbClr val="F8FAFC"/>
           </a:solidFill>
-          <a:ln w="19050">
+          <a:ln w="25400">
             <a:solidFill>
               <a:srgbClr val="0D9488"/>
             </a:solidFill>
@@ -3895,8 +3941,8 @@
         </p:nvSpPr>
         <p:spPr>
           <a:xfrm>
-            <a:off x="8046720" y="1280160"/>
-            <a:ext cx="3413455" cy="640080"/>
+            <a:off x="8046720" y="1325880"/>
+            <a:ext cx="3413455" cy="685800"/>
           </a:xfrm>
           <a:prstGeom prst="roundRect">
             <a:avLst/>
@@ -3938,8 +3984,8 @@
         </p:nvSpPr>
         <p:spPr>
           <a:xfrm>
-            <a:off x="8138160" y="1325880"/>
-            <a:ext cx="3230575" cy="548640"/>
+            <a:off x="8138160" y="1371600"/>
+            <a:ext cx="3230575" cy="594360"/>
           </a:xfrm>
           <a:prstGeom prst="rect">
             <a:avLst/>
@@ -3953,7 +3999,7 @@
           <a:lstStyle/>
           <a:p>
             <a:pPr algn="ctr">
-              <a:defRPr sz="1300" b="1">
+              <a:defRPr sz="1400" b="1">
                 <a:solidFill>
                   <a:srgbClr val="FFFFFF"/>
                 </a:solidFill>
@@ -3973,8 +4019,8 @@
         </p:nvSpPr>
         <p:spPr>
           <a:xfrm>
-            <a:off x="8229600" y="2011680"/>
-            <a:ext cx="3047695" cy="4114800"/>
+            <a:off x="8229600" y="2103120"/>
+            <a:ext cx="3047695" cy="4206240"/>
           </a:xfrm>
           <a:prstGeom prst="rect">
             <a:avLst/>
@@ -3989,11 +4035,11 @@
           <a:p>
             <a:pPr>
               <a:spcAft>
-                <a:spcPts val="1200"/>
+                <a:spcPts val="1000"/>
               </a:spcAft>
             </a:pPr>
             <a:r>
-              <a:rPr b="1" sz="1100">
+              <a:rPr b="1" sz="1150">
                 <a:solidFill>
                   <a:srgbClr val="0F172A"/>
                 </a:solidFill>
@@ -4001,22 +4047,22 @@
               <a:t>• Sequence Breakthrough: </a:t>
             </a:r>
             <a:r>
-              <a:rPr sz="1050">
+              <a:rPr sz="1100">
                 <a:solidFill>
                   <a:srgbClr val="475569"/>
                 </a:solidFill>
               </a:rPr>
-              <a:t>7x recall gain on Lateral Movement (51.95% vs 44.16% @ Top 2.5% budget) over static rules alone.</a:t>
+              <a:t>+6 Lateral Movement Catches: Lifts recall from 44.16% (34/77) to 51.95% (40/77) @ Top 2.5% budget over static rules.</a:t>
             </a:r>
           </a:p>
           <a:p>
             <a:pPr>
               <a:spcAft>
-                <a:spcPts val="1200"/>
+                <a:spcPts val="1000"/>
               </a:spcAft>
             </a:pPr>
             <a:r>
-              <a:rPr b="1" sz="1100">
+              <a:rPr b="1" sz="1150">
                 <a:solidFill>
                   <a:srgbClr val="0F172A"/>
                 </a:solidFill>
@@ -4024,7 +4070,7 @@
               <a:t>• Monotonic Additive Blend: </a:t>
             </a:r>
             <a:r>
-              <a:rPr sz="1050">
+              <a:rPr sz="1100">
                 <a:solidFill>
                   <a:srgbClr val="475569"/>
                 </a:solidFill>
@@ -4035,11 +4081,11 @@
           <a:p>
             <a:pPr>
               <a:spcAft>
-                <a:spcPts val="1200"/>
+                <a:spcPts val="1000"/>
               </a:spcAft>
             </a:pPr>
             <a:r>
-              <a:rPr b="1" sz="1100">
+              <a:rPr b="1" sz="1150">
                 <a:solidFill>
                   <a:srgbClr val="0F172A"/>
                 </a:solidFill>
@@ -4047,12 +4093,35 @@
               <a:t>• Empirical Validation: </a:t>
             </a:r>
             <a:r>
-              <a:rPr sz="1050">
+              <a:rPr sz="1100">
                 <a:solidFill>
                   <a:srgbClr val="475569"/>
                 </a:solidFill>
               </a:rPr>
-              <a:t>Verified over 60 days of telemetry (145,290 events), boosting PR-AUC from 0.7201 to 0.7475.</a:t>
+              <a:t>Verified over 60 days of enterprise telemetry (145,290 events), boosting Core PR-AUC from 0.7201 to 0.7475.</a:t>
+            </a:r>
+          </a:p>
+          <a:p>
+            <a:pPr>
+              <a:spcAft>
+                <a:spcPts val="1000"/>
+              </a:spcAft>
+            </a:pPr>
+            <a:r>
+              <a:rPr b="1" sz="1150">
+                <a:solidFill>
+                  <a:srgbClr val="0F172A"/>
+                </a:solidFill>
+              </a:rPr>
+              <a:t>• Explainable AI (XAI): </a:t>
+            </a:r>
+            <a:r>
+              <a:rPr sz="1100">
+                <a:solidFill>
+                  <a:srgbClr val="475569"/>
+                </a:solidFill>
+              </a:rPr>
+              <a:t>Generates automated human-readable incident narratives for every escalation in the triage queue.</a:t>
             </a:r>
           </a:p>
         </p:txBody>
@@ -4091,7 +4160,7 @@
         </p:nvSpPr>
         <p:spPr>
           <a:xfrm>
-            <a:off x="731520" y="365760"/>
+            <a:off x="731520" y="320040"/>
             <a:ext cx="10728655" cy="822960"/>
           </a:xfrm>
           <a:prstGeom prst="rect">
@@ -4106,7 +4175,7 @@
           <a:lstStyle/>
           <a:p>
             <a:pPr>
-              <a:defRPr sz="1100" b="1">
+              <a:defRPr sz="1200" b="1">
                 <a:solidFill>
                   <a:srgbClr val="0284C7"/>
                 </a:solidFill>
@@ -4119,7 +4188,7 @@
           </a:p>
           <a:p>
             <a:pPr>
-              <a:defRPr sz="2200" b="1">
+              <a:defRPr sz="2400" b="1">
                 <a:solidFill>
                   <a:srgbClr val="0F172A"/>
                 </a:solidFill>
@@ -4140,8 +4209,8 @@
         </p:nvSpPr>
         <p:spPr>
           <a:xfrm>
-            <a:off x="731520" y="1371600"/>
-            <a:ext cx="1965960" cy="1920240"/>
+            <a:off x="731520" y="1325880"/>
+            <a:ext cx="1965960" cy="2011680"/>
           </a:xfrm>
           <a:prstGeom prst="roundRect">
             <a:avLst/>
@@ -4149,7 +4218,7 @@
           <a:solidFill>
             <a:srgbClr val="F8FAFC"/>
           </a:solidFill>
-          <a:ln w="19050">
+          <a:ln w="25400">
             <a:solidFill>
               <a:srgbClr val="0D9488"/>
             </a:solidFill>
@@ -4185,8 +4254,8 @@
         </p:nvSpPr>
         <p:spPr>
           <a:xfrm>
-            <a:off x="822960" y="1463040"/>
-            <a:ext cx="1783080" cy="1737360"/>
+            <a:off x="822960" y="1417320"/>
+            <a:ext cx="1783080" cy="1828800"/>
           </a:xfrm>
           <a:prstGeom prst="rect">
             <a:avLst/>
@@ -4200,7 +4269,7 @@
           <a:lstStyle/>
           <a:p>
             <a:pPr>
-              <a:defRPr sz="1100" b="1">
+              <a:defRPr sz="1200" b="1">
                 <a:solidFill>
                   <a:srgbClr val="0F172A"/>
                 </a:solidFill>
@@ -4215,7 +4284,7 @@
               <a:spcBef>
                 <a:spcPts val="600"/>
               </a:spcBef>
-              <a:defRPr sz="950">
+              <a:defRPr sz="1050">
                 <a:solidFill>
                   <a:srgbClr val="475569"/>
                 </a:solidFill>
@@ -4243,7 +4312,7 @@
         </p:nvSpPr>
         <p:spPr>
           <a:xfrm>
-            <a:off x="2743200" y="2103120"/>
+            <a:off x="2743200" y="2148840"/>
             <a:ext cx="182880" cy="320040"/>
           </a:xfrm>
           <a:prstGeom prst="rightArrow">
@@ -4286,8 +4355,8 @@
         </p:nvSpPr>
         <p:spPr>
           <a:xfrm>
-            <a:off x="2971800" y="1371600"/>
-            <a:ext cx="1965960" cy="1920240"/>
+            <a:off x="2971800" y="1325880"/>
+            <a:ext cx="1965960" cy="2011680"/>
           </a:xfrm>
           <a:prstGeom prst="roundRect">
             <a:avLst/>
@@ -4295,7 +4364,7 @@
           <a:solidFill>
             <a:srgbClr val="F8FAFC"/>
           </a:solidFill>
-          <a:ln w="19050">
+          <a:ln w="25400">
             <a:solidFill>
               <a:srgbClr val="0D9488"/>
             </a:solidFill>
@@ -4331,8 +4400,8 @@
         </p:nvSpPr>
         <p:spPr>
           <a:xfrm>
-            <a:off x="3063240" y="1463040"/>
-            <a:ext cx="1783080" cy="1737360"/>
+            <a:off x="3063240" y="1417320"/>
+            <a:ext cx="1783080" cy="1828800"/>
           </a:xfrm>
           <a:prstGeom prst="rect">
             <a:avLst/>
@@ -4346,7 +4415,7 @@
           <a:lstStyle/>
           <a:p>
             <a:pPr>
-              <a:defRPr sz="1100" b="1">
+              <a:defRPr sz="1200" b="1">
                 <a:solidFill>
                   <a:srgbClr val="0F172A"/>
                 </a:solidFill>
@@ -4361,7 +4430,7 @@
               <a:spcBef>
                 <a:spcPts val="600"/>
               </a:spcBef>
-              <a:defRPr sz="950">
+              <a:defRPr sz="1050">
                 <a:solidFill>
                   <a:srgbClr val="475569"/>
                 </a:solidFill>
@@ -4389,7 +4458,7 @@
         </p:nvSpPr>
         <p:spPr>
           <a:xfrm>
-            <a:off x="4983480" y="2103120"/>
+            <a:off x="4983480" y="2148840"/>
             <a:ext cx="182880" cy="320040"/>
           </a:xfrm>
           <a:prstGeom prst="rightArrow">
@@ -4432,8 +4501,8 @@
         </p:nvSpPr>
         <p:spPr>
           <a:xfrm>
-            <a:off x="5212080" y="1371600"/>
-            <a:ext cx="1965960" cy="1920240"/>
+            <a:off x="5212080" y="1325880"/>
+            <a:ext cx="1965960" cy="2011680"/>
           </a:xfrm>
           <a:prstGeom prst="roundRect">
             <a:avLst/>
@@ -4441,7 +4510,7 @@
           <a:solidFill>
             <a:srgbClr val="F8FAFC"/>
           </a:solidFill>
-          <a:ln w="19050">
+          <a:ln w="25400">
             <a:solidFill>
               <a:srgbClr val="0D9488"/>
             </a:solidFill>
@@ -4477,8 +4546,8 @@
         </p:nvSpPr>
         <p:spPr>
           <a:xfrm>
-            <a:off x="5303520" y="1463040"/>
-            <a:ext cx="1783080" cy="1737360"/>
+            <a:off x="5303520" y="1417320"/>
+            <a:ext cx="1783080" cy="1828800"/>
           </a:xfrm>
           <a:prstGeom prst="rect">
             <a:avLst/>
@@ -4492,7 +4561,7 @@
           <a:lstStyle/>
           <a:p>
             <a:pPr>
-              <a:defRPr sz="1100" b="1">
+              <a:defRPr sz="1200" b="1">
                 <a:solidFill>
                   <a:srgbClr val="0F172A"/>
                 </a:solidFill>
@@ -4507,7 +4576,7 @@
               <a:spcBef>
                 <a:spcPts val="600"/>
               </a:spcBef>
-              <a:defRPr sz="950">
+              <a:defRPr sz="1050">
                 <a:solidFill>
                   <a:srgbClr val="475569"/>
                 </a:solidFill>
@@ -4535,7 +4604,7 @@
         </p:nvSpPr>
         <p:spPr>
           <a:xfrm>
-            <a:off x="7223760" y="2103120"/>
+            <a:off x="7223760" y="2148840"/>
             <a:ext cx="182880" cy="320040"/>
           </a:xfrm>
           <a:prstGeom prst="rightArrow">
@@ -4578,8 +4647,8 @@
         </p:nvSpPr>
         <p:spPr>
           <a:xfrm>
-            <a:off x="7452360" y="1371600"/>
-            <a:ext cx="1965960" cy="1920240"/>
+            <a:off x="7452360" y="1325880"/>
+            <a:ext cx="1965960" cy="2011680"/>
           </a:xfrm>
           <a:prstGeom prst="roundRect">
             <a:avLst/>
@@ -4587,7 +4656,7 @@
           <a:solidFill>
             <a:srgbClr val="F8FAFC"/>
           </a:solidFill>
-          <a:ln w="19050">
+          <a:ln w="25400">
             <a:solidFill>
               <a:srgbClr val="0284C7"/>
             </a:solidFill>
@@ -4623,8 +4692,8 @@
         </p:nvSpPr>
         <p:spPr>
           <a:xfrm>
-            <a:off x="7543800" y="1463040"/>
-            <a:ext cx="1783080" cy="1737360"/>
+            <a:off x="7543800" y="1417320"/>
+            <a:ext cx="1783080" cy="1828800"/>
           </a:xfrm>
           <a:prstGeom prst="rect">
             <a:avLst/>
@@ -4638,7 +4707,7 @@
           <a:lstStyle/>
           <a:p>
             <a:pPr>
-              <a:defRPr sz="1100" b="1">
+              <a:defRPr sz="1200" b="1">
                 <a:solidFill>
                   <a:srgbClr val="0F172A"/>
                 </a:solidFill>
@@ -4653,7 +4722,7 @@
               <a:spcBef>
                 <a:spcPts val="600"/>
               </a:spcBef>
-              <a:defRPr sz="950">
+              <a:defRPr sz="1050">
                 <a:solidFill>
                   <a:srgbClr val="475569"/>
                 </a:solidFill>
@@ -4681,7 +4750,7 @@
         </p:nvSpPr>
         <p:spPr>
           <a:xfrm>
-            <a:off x="9464040" y="2103120"/>
+            <a:off x="9464040" y="2148840"/>
             <a:ext cx="182880" cy="320040"/>
           </a:xfrm>
           <a:prstGeom prst="rightArrow">
@@ -4724,8 +4793,111 @@
         </p:nvSpPr>
         <p:spPr>
           <a:xfrm>
-            <a:off x="9692640" y="1371600"/>
-            <a:ext cx="1965960" cy="1920240"/>
+            <a:off x="9692640" y="1325880"/>
+            <a:ext cx="1965960" cy="2011680"/>
+          </a:xfrm>
+          <a:prstGeom prst="roundRect">
+            <a:avLst/>
+          </a:prstGeom>
+          <a:solidFill>
+            <a:srgbClr val="F8FAFC"/>
+          </a:solidFill>
+          <a:ln w="25400">
+            <a:solidFill>
+              <a:srgbClr val="0284C7"/>
+            </a:solidFill>
+          </a:ln>
+        </p:spPr>
+        <p:style>
+          <a:lnRef idx="1">
+            <a:schemeClr val="accent1"/>
+          </a:lnRef>
+          <a:fillRef idx="3">
+            <a:schemeClr val="accent1"/>
+          </a:fillRef>
+          <a:effectRef idx="2">
+            <a:schemeClr val="accent1"/>
+          </a:effectRef>
+          <a:fontRef idx="minor">
+            <a:schemeClr val="lt1"/>
+          </a:fontRef>
+        </p:style>
+        <p:txBody>
+          <a:bodyPr rtlCol="0" anchor="ctr"/>
+          <a:lstStyle/>
+          <a:p>
+            <a:pPr algn="ctr"/>
+          </a:p>
+        </p:txBody>
+      </p:sp>
+      <p:sp>
+        <p:nvSpPr>
+          <p:cNvPr id="16" name="TextBox 15"/>
+          <p:cNvSpPr txBox="1"/>
+          <p:nvPr/>
+        </p:nvSpPr>
+        <p:spPr>
+          <a:xfrm>
+            <a:off x="9784080" y="1417320"/>
+            <a:ext cx="1783080" cy="1828800"/>
+          </a:xfrm>
+          <a:prstGeom prst="rect">
+            <a:avLst/>
+          </a:prstGeom>
+          <a:noFill/>
+        </p:spPr>
+        <p:txBody>
+          <a:bodyPr wrap="square">
+            <a:spAutoFit/>
+          </a:bodyPr>
+          <a:lstStyle/>
+          <a:p>
+            <a:pPr>
+              <a:defRPr sz="1200" b="1">
+                <a:solidFill>
+                  <a:srgbClr val="0F172A"/>
+                </a:solidFill>
+              </a:defRPr>
+            </a:pPr>
+            <a:r>
+              <a:t>5. SOC Dashboard</a:t>
+            </a:r>
+          </a:p>
+          <a:p>
+            <a:pPr>
+              <a:spcBef>
+                <a:spcPts val="600"/>
+              </a:spcBef>
+              <a:defRPr sz="1050">
+                <a:solidFill>
+                  <a:srgbClr val="475569"/>
+                </a:solidFill>
+              </a:defRPr>
+            </a:pPr>
+            <a:r>
+              <a:t>Glassmorphic Web Command Center</a:t>
+            </a:r>
+            <a:br/>
+            <a:r>
+              <a:t>Live Chart.js KPIs + Narratives</a:t>
+            </a:r>
+            <a:br/>
+            <a:r>
+              <a:t>Interactive Feature Attribution</a:t>
+            </a:r>
+          </a:p>
+        </p:txBody>
+      </p:sp>
+      <p:sp>
+        <p:nvSpPr>
+          <p:cNvPr id="17" name="Rounded Rectangle 16"/>
+          <p:cNvSpPr/>
+          <p:nvPr/>
+        </p:nvSpPr>
+        <p:spPr>
+          <a:xfrm>
+            <a:off x="731520" y="3520440"/>
+            <a:ext cx="10728655" cy="2926080"/>
           </a:xfrm>
           <a:prstGeom prst="roundRect">
             <a:avLst/>
@@ -4735,7 +4907,7 @@
           </a:solidFill>
           <a:ln w="19050">
             <a:solidFill>
-              <a:srgbClr val="0284C7"/>
+              <a:srgbClr val="CBD5E1"/>
             </a:solidFill>
           </a:ln>
         </p:spPr>
@@ -4763,14 +4935,14 @@
       </p:sp>
       <p:sp>
         <p:nvSpPr>
-          <p:cNvPr id="16" name="TextBox 15"/>
+          <p:cNvPr id="18" name="TextBox 17"/>
           <p:cNvSpPr txBox="1"/>
           <p:nvPr/>
         </p:nvSpPr>
         <p:spPr>
           <a:xfrm>
-            <a:off x="9784080" y="1463040"/>
-            <a:ext cx="1783080" cy="1737360"/>
+            <a:off x="1005840" y="3657600"/>
+            <a:ext cx="10180015" cy="2651760"/>
           </a:xfrm>
           <a:prstGeom prst="rect">
             <a:avLst/>
@@ -4784,204 +4956,101 @@
           <a:lstStyle/>
           <a:p>
             <a:pPr>
-              <a:defRPr sz="1100" b="1">
+              <a:defRPr sz="1400" b="1">
+                <a:solidFill>
+                  <a:srgbClr val="0284C7"/>
+                </a:solidFill>
+              </a:defRPr>
+            </a:pPr>
+            <a:r>
+              <a:t>TECHNOLOGY STACK &amp; METHODOLOGY</a:t>
+            </a:r>
+          </a:p>
+          <a:p>
+            <a:pPr>
+              <a:spcAft>
+                <a:spcPts val="800"/>
+              </a:spcAft>
+            </a:pPr>
+            <a:r>
+              <a:rPr b="1" sz="1200">
                 <a:solidFill>
                   <a:srgbClr val="0F172A"/>
                 </a:solidFill>
-              </a:defRPr>
-            </a:pPr>
-            <a:r>
-              <a:t>5. SOC Dashboard</a:t>
-            </a:r>
-          </a:p>
-          <a:p>
-            <a:pPr>
-              <a:spcBef>
-                <a:spcPts val="600"/>
-              </a:spcBef>
-              <a:defRPr sz="950">
+              </a:rPr>
+              <a:t>• Core Machine Learning Stack:     </a:t>
+            </a:r>
+            <a:r>
+              <a:rPr sz="1150">
                 <a:solidFill>
                   <a:srgbClr val="475569"/>
                 </a:solidFill>
-              </a:defRPr>
-            </a:pPr>
-            <a:r>
-              <a:t>Glassmorphic Web Command Center</a:t>
-            </a:r>
-            <a:br/>
-            <a:r>
-              <a:t>Live Chart.js KPIs + Narratives</a:t>
-            </a:r>
-            <a:br/>
-            <a:r>
-              <a:t>Interactive Feature Attribution</a:t>
-            </a:r>
-          </a:p>
-        </p:txBody>
-      </p:sp>
-      <p:sp>
-        <p:nvSpPr>
-          <p:cNvPr id="17" name="Rounded Rectangle 16"/>
-          <p:cNvSpPr/>
-          <p:nvPr/>
-        </p:nvSpPr>
-        <p:spPr>
-          <a:xfrm>
-            <a:off x="731520" y="3474720"/>
-            <a:ext cx="10728655" cy="2926080"/>
-          </a:xfrm>
-          <a:prstGeom prst="roundRect">
-            <a:avLst/>
-          </a:prstGeom>
-          <a:solidFill>
-            <a:srgbClr val="F8FAFC"/>
-          </a:solidFill>
-          <a:ln w="12700">
-            <a:solidFill>
-              <a:srgbClr val="CBD5E1"/>
-            </a:solidFill>
-          </a:ln>
-        </p:spPr>
-        <p:style>
-          <a:lnRef idx="1">
-            <a:schemeClr val="accent1"/>
-          </a:lnRef>
-          <a:fillRef idx="3">
-            <a:schemeClr val="accent1"/>
-          </a:fillRef>
-          <a:effectRef idx="2">
-            <a:schemeClr val="accent1"/>
-          </a:effectRef>
-          <a:fontRef idx="minor">
-            <a:schemeClr val="lt1"/>
-          </a:fontRef>
-        </p:style>
-        <p:txBody>
-          <a:bodyPr rtlCol="0" anchor="ctr"/>
-          <a:lstStyle/>
-          <a:p>
-            <a:pPr algn="ctr"/>
-          </a:p>
-        </p:txBody>
-      </p:sp>
-      <p:sp>
-        <p:nvSpPr>
-          <p:cNvPr id="18" name="TextBox 17"/>
-          <p:cNvSpPr txBox="1"/>
-          <p:nvPr/>
-        </p:nvSpPr>
-        <p:spPr>
-          <a:xfrm>
-            <a:off x="914400" y="3566160"/>
-            <a:ext cx="10362895" cy="2743200"/>
-          </a:xfrm>
-          <a:prstGeom prst="rect">
-            <a:avLst/>
-          </a:prstGeom>
-          <a:noFill/>
-        </p:spPr>
-        <p:txBody>
-          <a:bodyPr wrap="square">
-            <a:spAutoFit/>
-          </a:bodyPr>
-          <a:lstStyle/>
-          <a:p>
-            <a:pPr>
-              <a:defRPr sz="1300" b="1">
-                <a:solidFill>
-                  <a:srgbClr val="0284C7"/>
-                </a:solidFill>
-              </a:defRPr>
-            </a:pPr>
-            <a:r>
-              <a:t>TECHNOLOGY STACK &amp; METHODOLOGY</a:t>
+              </a:rPr>
+              <a:t>Python 3.12, PyTorch (LSTM Autoencoders), Scikit-Learn (Isolation Forest), Pandas, NumPy</a:t>
             </a:r>
           </a:p>
           <a:p>
             <a:pPr>
               <a:spcAft>
-                <a:spcPts val="600"/>
+                <a:spcPts val="800"/>
               </a:spcAft>
             </a:pPr>
             <a:r>
-              <a:rPr b="1" sz="1100">
+              <a:rPr b="1" sz="1200">
                 <a:solidFill>
                   <a:srgbClr val="0F172A"/>
                 </a:solidFill>
               </a:rPr>
-              <a:t>• Core Machine Learning Stack:     </a:t>
-            </a:r>
-            <a:r>
-              <a:rPr sz="1050">
+              <a:t>• Frontend &amp; SOC Command Center:   </a:t>
+            </a:r>
+            <a:r>
+              <a:rPr sz="1150">
                 <a:solidFill>
                   <a:srgbClr val="475569"/>
                 </a:solidFill>
               </a:rPr>
-              <a:t>Python 3.12, PyTorch (LSTM Autoencoders), Scikit-Learn (Isolation Forest), Pandas, NumPy</a:t>
+              <a:t>Vanilla JavaScript (ES6+), HTML5, CSS3 Glassmorphic UI, Chart.js Visual Analytics Suite</a:t>
             </a:r>
           </a:p>
           <a:p>
             <a:pPr>
               <a:spcAft>
-                <a:spcPts val="600"/>
+                <a:spcPts val="800"/>
               </a:spcAft>
             </a:pPr>
             <a:r>
-              <a:rPr b="1" sz="1100">
+              <a:rPr b="1" sz="1200">
                 <a:solidFill>
                   <a:srgbClr val="0F172A"/>
                 </a:solidFill>
               </a:rPr>
-              <a:t>• Frontend &amp; SOC Command Center:   </a:t>
-            </a:r>
-            <a:r>
-              <a:rPr sz="1050">
+              <a:t>• Mathematical Hybrid Formulation: </a:t>
+            </a:r>
+            <a:r>
+              <a:rPr sz="1150">
                 <a:solidFill>
                   <a:srgbClr val="475569"/>
                 </a:solidFill>
               </a:rPr>
-              <a:t>Vanilla JavaScript (ES6+), HTML5, CSS3 Glassmorphic UI, Chart.js Visual Analytics Suite</a:t>
+              <a:t>HybridScore = BaseScore if BaseScore &gt;= 3.0 else BaseScore + 0.99 * LSTM_pct (res_recent &gt;= 5)</a:t>
             </a:r>
           </a:p>
           <a:p>
             <a:pPr>
               <a:spcAft>
-                <a:spcPts val="600"/>
+                <a:spcPts val="800"/>
               </a:spcAft>
             </a:pPr>
             <a:r>
-              <a:rPr b="1" sz="1100">
+              <a:rPr b="1" sz="1200">
                 <a:solidFill>
                   <a:srgbClr val="0F172A"/>
                 </a:solidFill>
               </a:rPr>
-              <a:t>• Mathematical Hybrid Formulation: </a:t>
-            </a:r>
-            <a:r>
-              <a:rPr sz="1050">
-                <a:solidFill>
-                  <a:srgbClr val="475569"/>
-                </a:solidFill>
-              </a:rPr>
-              <a:t>HybridScore = BaseScore if BaseScore &gt;= 3.0 else BaseScore + 0.99 * LSTM_pct (res_recent &gt;= 5)</a:t>
-            </a:r>
-          </a:p>
-          <a:p>
-            <a:pPr>
-              <a:spcAft>
-                <a:spcPts val="600"/>
-              </a:spcAft>
-            </a:pPr>
-            <a:r>
-              <a:rPr b="1" sz="1100">
-                <a:solidFill>
-                  <a:srgbClr val="0F172A"/>
-                </a:solidFill>
-              </a:rPr>
               <a:t>• Unsupervised Training Rigor:     </a:t>
             </a:r>
             <a:r>
-              <a:rPr sz="1050">
+              <a:rPr sz="1150">
                 <a:solidFill>
                   <a:srgbClr val="475569"/>
                 </a:solidFill>
@@ -5025,7 +5094,7 @@
         </p:nvSpPr>
         <p:spPr>
           <a:xfrm>
-            <a:off x="731520" y="365760"/>
+            <a:off x="731520" y="320040"/>
             <a:ext cx="10728655" cy="822960"/>
           </a:xfrm>
           <a:prstGeom prst="rect">
@@ -5040,7 +5109,7 @@
           <a:lstStyle/>
           <a:p>
             <a:pPr>
-              <a:defRPr sz="1100" b="1">
+              <a:defRPr sz="1200" b="1">
                 <a:solidFill>
                   <a:srgbClr val="0284C7"/>
                 </a:solidFill>
@@ -5053,7 +5122,7 @@
           </a:p>
           <a:p>
             <a:pPr>
-              <a:defRPr sz="2200" b="1">
+              <a:defRPr sz="2400" b="1">
                 <a:solidFill>
                   <a:srgbClr val="0F172A"/>
                 </a:solidFill>
@@ -5074,8 +5143,8 @@
         </p:nvSpPr>
         <p:spPr>
           <a:xfrm>
-            <a:off x="731520" y="1280160"/>
-            <a:ext cx="3413455" cy="5029200"/>
+            <a:off x="731520" y="1325880"/>
+            <a:ext cx="3413455" cy="5120640"/>
           </a:xfrm>
           <a:prstGeom prst="roundRect">
             <a:avLst/>
@@ -5083,7 +5152,7 @@
           <a:solidFill>
             <a:srgbClr val="F8FAFC"/>
           </a:solidFill>
-          <a:ln w="19050">
+          <a:ln w="25400">
             <a:solidFill>
               <a:srgbClr val="0284C7"/>
             </a:solidFill>
@@ -5119,8 +5188,8 @@
         </p:nvSpPr>
         <p:spPr>
           <a:xfrm>
-            <a:off x="731520" y="1280160"/>
-            <a:ext cx="3413455" cy="640080"/>
+            <a:off x="731520" y="1325880"/>
+            <a:ext cx="3413455" cy="685800"/>
           </a:xfrm>
           <a:prstGeom prst="roundRect">
             <a:avLst/>
@@ -5162,8 +5231,8 @@
         </p:nvSpPr>
         <p:spPr>
           <a:xfrm>
-            <a:off x="822960" y="1325880"/>
-            <a:ext cx="3230575" cy="548640"/>
+            <a:off x="822960" y="1371600"/>
+            <a:ext cx="3230575" cy="594360"/>
           </a:xfrm>
           <a:prstGeom prst="rect">
             <a:avLst/>
@@ -5177,7 +5246,7 @@
           <a:lstStyle/>
           <a:p>
             <a:pPr algn="ctr">
-              <a:defRPr sz="1300" b="1">
+              <a:defRPr sz="1400" b="1">
                 <a:solidFill>
                   <a:srgbClr val="FFFFFF"/>
                 </a:solidFill>
@@ -5197,8 +5266,8 @@
         </p:nvSpPr>
         <p:spPr>
           <a:xfrm>
-            <a:off x="914400" y="2011680"/>
-            <a:ext cx="3047695" cy="4114800"/>
+            <a:off x="914400" y="2103120"/>
+            <a:ext cx="3047695" cy="4206240"/>
           </a:xfrm>
           <a:prstGeom prst="rect">
             <a:avLst/>
@@ -5213,11 +5282,11 @@
           <a:p>
             <a:pPr>
               <a:spcAft>
-                <a:spcPts val="1200"/>
+                <a:spcPts val="1000"/>
               </a:spcAft>
             </a:pPr>
             <a:r>
-              <a:rPr b="1" sz="1100">
+              <a:rPr b="1" sz="1150">
                 <a:solidFill>
                   <a:srgbClr val="0F172A"/>
                 </a:solidFill>
@@ -5225,7 +5294,7 @@
               <a:t>• Native Log Compatibility: </a:t>
             </a:r>
             <a:r>
-              <a:rPr sz="1050">
+              <a:rPr sz="1100">
                 <a:solidFill>
                   <a:srgbClr val="475569"/>
                 </a:solidFill>
@@ -5236,11 +5305,11 @@
           <a:p>
             <a:pPr>
               <a:spcAft>
-                <a:spcPts val="1200"/>
+                <a:spcPts val="1000"/>
               </a:spcAft>
             </a:pPr>
             <a:r>
-              <a:rPr b="1" sz="1100">
+              <a:rPr b="1" sz="1150">
                 <a:solidFill>
                   <a:srgbClr val="0F172A"/>
                 </a:solidFill>
@@ -5248,22 +5317,22 @@
               <a:t>• Low-Latency Inference: </a:t>
             </a:r>
             <a:r>
-              <a:rPr sz="1050">
+              <a:rPr sz="1100">
                 <a:solidFill>
                   <a:srgbClr val="475569"/>
                 </a:solidFill>
               </a:rPr>
-              <a:t>Per-event scoring completes in &lt; 5ms, supporting real-time SIEM streaming.</a:t>
+              <a:t>Per-event scoring completes in &lt; 5ms, supporting real-time SIEM streaming ingestion.</a:t>
             </a:r>
           </a:p>
           <a:p>
             <a:pPr>
               <a:spcAft>
-                <a:spcPts val="1200"/>
+                <a:spcPts val="1000"/>
               </a:spcAft>
             </a:pPr>
             <a:r>
-              <a:rPr b="1" sz="1100">
+              <a:rPr b="1" sz="1150">
                 <a:solidFill>
                   <a:srgbClr val="0F172A"/>
                 </a:solidFill>
@@ -5271,12 +5340,35 @@
               <a:t>• Production Scalability: </a:t>
             </a:r>
             <a:r>
-              <a:rPr sz="1050">
+              <a:rPr sz="1100">
                 <a:solidFill>
                   <a:srgbClr val="475569"/>
                 </a:solidFill>
               </a:rPr>
               <a:t>Readily deployable as a Kafka / Flink microservice consumer in hybrid cloud environments.</a:t>
+            </a:r>
+          </a:p>
+          <a:p>
+            <a:pPr>
+              <a:spcAft>
+                <a:spcPts val="1000"/>
+              </a:spcAft>
+            </a:pPr>
+            <a:r>
+              <a:rPr b="1" sz="1150">
+                <a:solidFill>
+                  <a:srgbClr val="0F172A"/>
+                </a:solidFill>
+              </a:rPr>
+              <a:t>• Zero Model Overhead: </a:t>
+            </a:r>
+            <a:r>
+              <a:rPr sz="1100">
+                <a:solidFill>
+                  <a:srgbClr val="475569"/>
+                </a:solidFill>
+              </a:rPr>
+              <a:t>Compact LSTM architecture runs efficiently on standard CPU nodes without requiring expensive GPUs.</a:t>
             </a:r>
           </a:p>
         </p:txBody>
@@ -5289,8 +5381,8 @@
         </p:nvSpPr>
         <p:spPr>
           <a:xfrm>
-            <a:off x="4389120" y="1280160"/>
-            <a:ext cx="3413455" cy="5029200"/>
+            <a:off x="4389120" y="1325880"/>
+            <a:ext cx="3413455" cy="5120640"/>
           </a:xfrm>
           <a:prstGeom prst="roundRect">
             <a:avLst/>
@@ -5298,7 +5390,7 @@
           <a:solidFill>
             <a:srgbClr val="F8FAFC"/>
           </a:solidFill>
-          <a:ln w="19050">
+          <a:ln w="25400">
             <a:solidFill>
               <a:srgbClr val="D97706"/>
             </a:solidFill>
@@ -5334,8 +5426,8 @@
         </p:nvSpPr>
         <p:spPr>
           <a:xfrm>
-            <a:off x="4389120" y="1280160"/>
-            <a:ext cx="3413455" cy="640080"/>
+            <a:off x="4389120" y="1325880"/>
+            <a:ext cx="3413455" cy="685800"/>
           </a:xfrm>
           <a:prstGeom prst="roundRect">
             <a:avLst/>
@@ -5377,8 +5469,8 @@
         </p:nvSpPr>
         <p:spPr>
           <a:xfrm>
-            <a:off x="4480560" y="1325880"/>
-            <a:ext cx="3230575" cy="548640"/>
+            <a:off x="4480560" y="1371600"/>
+            <a:ext cx="3230575" cy="594360"/>
           </a:xfrm>
           <a:prstGeom prst="rect">
             <a:avLst/>
@@ -5392,7 +5484,7 @@
           <a:lstStyle/>
           <a:p>
             <a:pPr algn="ctr">
-              <a:defRPr sz="1300" b="1">
+              <a:defRPr sz="1400" b="1">
                 <a:solidFill>
                   <a:srgbClr val="FFFFFF"/>
                 </a:solidFill>
@@ -5412,8 +5504,8 @@
         </p:nvSpPr>
         <p:spPr>
           <a:xfrm>
-            <a:off x="4572000" y="2011680"/>
-            <a:ext cx="3047695" cy="4114800"/>
+            <a:off x="4572000" y="2103120"/>
+            <a:ext cx="3047695" cy="4206240"/>
           </a:xfrm>
           <a:prstGeom prst="rect">
             <a:avLst/>
@@ -5428,11 +5520,11 @@
           <a:p>
             <a:pPr>
               <a:spcAft>
-                <a:spcPts val="1200"/>
+                <a:spcPts val="1000"/>
               </a:spcAft>
             </a:pPr>
             <a:r>
-              <a:rPr b="1" sz="1100">
+              <a:rPr b="1" sz="1150">
                 <a:solidFill>
                   <a:srgbClr val="0F172A"/>
                 </a:solidFill>
@@ -5440,7 +5532,7 @@
               <a:t>• Alert Budget Displacement: </a:t>
             </a:r>
             <a:r>
-              <a:rPr sz="1050">
+              <a:rPr sz="1100">
                 <a:solidFill>
                   <a:srgbClr val="475569"/>
                 </a:solidFill>
@@ -5451,11 +5543,11 @@
           <a:p>
             <a:pPr>
               <a:spcAft>
-                <a:spcPts val="1200"/>
+                <a:spcPts val="1000"/>
               </a:spcAft>
             </a:pPr>
             <a:r>
-              <a:rPr b="1" sz="1100">
+              <a:rPr b="1" sz="1150">
                 <a:solidFill>
                   <a:srgbClr val="0F172A"/>
                 </a:solidFill>
@@ -5463,7 +5555,7 @@
               <a:t>• Sparse Entity Cold-Start: </a:t>
             </a:r>
             <a:r>
-              <a:rPr sz="1050">
+              <a:rPr sz="1100">
                 <a:solidFill>
                   <a:srgbClr val="475569"/>
                 </a:solidFill>
@@ -5474,11 +5566,11 @@
           <a:p>
             <a:pPr>
               <a:spcAft>
-                <a:spcPts val="1200"/>
+                <a:spcPts val="1000"/>
               </a:spcAft>
             </a:pPr>
             <a:r>
-              <a:rPr b="1" sz="1100">
+              <a:rPr b="1" sz="1150">
                 <a:solidFill>
                   <a:srgbClr val="0F172A"/>
                 </a:solidFill>
@@ -5486,12 +5578,35 @@
               <a:t>• Operational Queue Saturation: </a:t>
             </a:r>
             <a:r>
-              <a:rPr sz="1050">
+              <a:rPr sz="1100">
                 <a:solidFill>
                   <a:srgbClr val="475569"/>
                 </a:solidFill>
               </a:rPr>
-              <a:t>Surges in daily traffic can flood analyst triage queues during peak hours.</a:t>
+              <a:t>Surges in daily traffic can flood analyst triage queues during peak activity hours.</a:t>
+            </a:r>
+          </a:p>
+          <a:p>
+            <a:pPr>
+              <a:spcAft>
+                <a:spcPts val="1000"/>
+              </a:spcAft>
+            </a:pPr>
+            <a:r>
+              <a:rPr b="1" sz="1150">
+                <a:solidFill>
+                  <a:srgbClr val="0F172A"/>
+                </a:solidFill>
+              </a:rPr>
+              <a:t>• Adversarial Evasion: </a:t>
+            </a:r>
+            <a:r>
+              <a:rPr sz="1100">
+                <a:solidFill>
+                  <a:srgbClr val="475569"/>
+                </a:solidFill>
+              </a:rPr>
+              <a:t>Attractors throttling attack velocity to remain under Z-score statistical limits.</a:t>
             </a:r>
           </a:p>
         </p:txBody>
@@ -5504,8 +5619,8 @@
         </p:nvSpPr>
         <p:spPr>
           <a:xfrm>
-            <a:off x="8046720" y="1280160"/>
-            <a:ext cx="3413455" cy="5029200"/>
+            <a:off x="8046720" y="1325880"/>
+            <a:ext cx="3413455" cy="5120640"/>
           </a:xfrm>
           <a:prstGeom prst="roundRect">
             <a:avLst/>
@@ -5513,7 +5628,7 @@
           <a:solidFill>
             <a:srgbClr val="F8FAFC"/>
           </a:solidFill>
-          <a:ln w="19050">
+          <a:ln w="25400">
             <a:solidFill>
               <a:srgbClr val="0D9488"/>
             </a:solidFill>
@@ -5549,8 +5664,8 @@
         </p:nvSpPr>
         <p:spPr>
           <a:xfrm>
-            <a:off x="8046720" y="1280160"/>
-            <a:ext cx="3413455" cy="640080"/>
+            <a:off x="8046720" y="1325880"/>
+            <a:ext cx="3413455" cy="685800"/>
           </a:xfrm>
           <a:prstGeom prst="roundRect">
             <a:avLst/>
@@ -5592,8 +5707,8 @@
         </p:nvSpPr>
         <p:spPr>
           <a:xfrm>
-            <a:off x="8138160" y="1325880"/>
-            <a:ext cx="3230575" cy="548640"/>
+            <a:off x="8138160" y="1371600"/>
+            <a:ext cx="3230575" cy="594360"/>
           </a:xfrm>
           <a:prstGeom prst="rect">
             <a:avLst/>
@@ -5607,7 +5722,7 @@
           <a:lstStyle/>
           <a:p>
             <a:pPr algn="ctr">
-              <a:defRPr sz="1300" b="1">
+              <a:defRPr sz="1400" b="1">
                 <a:solidFill>
                   <a:srgbClr val="FFFFFF"/>
                 </a:solidFill>
@@ -5627,8 +5742,8 @@
         </p:nvSpPr>
         <p:spPr>
           <a:xfrm>
-            <a:off x="8229600" y="2011680"/>
-            <a:ext cx="3047695" cy="4114800"/>
+            <a:off x="8229600" y="2103120"/>
+            <a:ext cx="3047695" cy="4206240"/>
           </a:xfrm>
           <a:prstGeom prst="rect">
             <a:avLst/>
@@ -5643,11 +5758,11 @@
           <a:p>
             <a:pPr>
               <a:spcAft>
-                <a:spcPts val="1200"/>
+                <a:spcPts val="1000"/>
               </a:spcAft>
             </a:pPr>
             <a:r>
-              <a:rPr b="1" sz="1100">
+              <a:rPr b="1" sz="1150">
                 <a:solidFill>
                   <a:srgbClr val="0F172A"/>
                 </a:solidFill>
@@ -5655,7 +5770,7 @@
               <a:t>• Monotonic Blend Floor: </a:t>
             </a:r>
             <a:r>
-              <a:rPr sz="1050">
+              <a:rPr sz="1100">
                 <a:solidFill>
                   <a:srgbClr val="475569"/>
                 </a:solidFill>
@@ -5666,11 +5781,11 @@
           <a:p>
             <a:pPr>
               <a:spcAft>
-                <a:spcPts val="1200"/>
+                <a:spcPts val="1000"/>
               </a:spcAft>
             </a:pPr>
             <a:r>
-              <a:rPr b="1" sz="1100">
+              <a:rPr b="1" sz="1150">
                 <a:solidFill>
                   <a:srgbClr val="0F172A"/>
                 </a:solidFill>
@@ -5678,7 +5793,7 @@
               <a:t>• Population Fallback Profiles: </a:t>
             </a:r>
             <a:r>
-              <a:rPr sz="1050">
+              <a:rPr sz="1100">
                 <a:solidFill>
                   <a:srgbClr val="475569"/>
                 </a:solidFill>
@@ -5689,11 +5804,11 @@
           <a:p>
             <a:pPr>
               <a:spcAft>
-                <a:spcPts val="1200"/>
+                <a:spcPts val="1000"/>
               </a:spcAft>
             </a:pPr>
             <a:r>
-              <a:rPr b="1" sz="1100">
+              <a:rPr b="1" sz="1150">
                 <a:solidFill>
                   <a:srgbClr val="0F172A"/>
                 </a:solidFill>
@@ -5701,12 +5816,35 @@
               <a:t>• Targeted Sequence Amplification: </a:t>
             </a:r>
             <a:r>
-              <a:rPr sz="1050">
+              <a:rPr sz="1100">
                 <a:solidFill>
                   <a:srgbClr val="475569"/>
                 </a:solidFill>
               </a:rPr>
               <a:t>Percentile sequence boost triggers only on high-traversal entities (`res_recent &gt;= 5`).</a:t>
+            </a:r>
+          </a:p>
+          <a:p>
+            <a:pPr>
+              <a:spcAft>
+                <a:spcPts val="1000"/>
+              </a:spcAft>
+            </a:pPr>
+            <a:r>
+              <a:rPr b="1" sz="1150">
+                <a:solidFill>
+                  <a:srgbClr val="0F172A"/>
+                </a:solidFill>
+              </a:rPr>
+              <a:t>• Adaptive Velocity Profiling: </a:t>
+            </a:r>
+            <a:r>
+              <a:rPr sz="1100">
+                <a:solidFill>
+                  <a:srgbClr val="475569"/>
+                </a:solidFill>
+              </a:rPr>
+              <a:t>Multi-window tracking detects low-and-slow attacks across extended 60-day horizons.</a:t>
             </a:r>
           </a:p>
         </p:txBody>
@@ -5745,7 +5883,7 @@
         </p:nvSpPr>
         <p:spPr>
           <a:xfrm>
-            <a:off x="731520" y="365760"/>
+            <a:off x="731520" y="320040"/>
             <a:ext cx="10728655" cy="822960"/>
           </a:xfrm>
           <a:prstGeom prst="rect">
@@ -5760,7 +5898,7 @@
           <a:lstStyle/>
           <a:p>
             <a:pPr>
-              <a:defRPr sz="1100" b="1">
+              <a:defRPr sz="1200" b="1">
                 <a:solidFill>
                   <a:srgbClr val="0284C7"/>
                 </a:solidFill>
@@ -5773,7 +5911,7 @@
           </a:p>
           <a:p>
             <a:pPr>
-              <a:defRPr sz="2200" b="1">
+              <a:defRPr sz="2400" b="1">
                 <a:solidFill>
                   <a:srgbClr val="0F172A"/>
                 </a:solidFill>
@@ -5802,7 +5940,7 @@
         </p:blipFill>
         <p:spPr>
           <a:xfrm>
-            <a:off x="731520" y="1371600"/>
+            <a:off x="731520" y="1325880"/>
             <a:ext cx="6583680" cy="12241385"/>
           </a:xfrm>
           <a:prstGeom prst="rect">
@@ -5818,8 +5956,8 @@
         </p:nvSpPr>
         <p:spPr>
           <a:xfrm>
-            <a:off x="7589520" y="1371600"/>
-            <a:ext cx="3870655" cy="4937760"/>
+            <a:off x="7589520" y="1325880"/>
+            <a:ext cx="3870655" cy="5120640"/>
           </a:xfrm>
           <a:prstGeom prst="roundRect">
             <a:avLst/>
@@ -5827,7 +5965,7 @@
           <a:solidFill>
             <a:srgbClr val="F8FAFC"/>
           </a:solidFill>
-          <a:ln w="19050">
+          <a:ln w="25400">
             <a:solidFill>
               <a:srgbClr val="0284C7"/>
             </a:solidFill>
@@ -5863,8 +6001,8 @@
         </p:nvSpPr>
         <p:spPr>
           <a:xfrm>
-            <a:off x="7772400" y="1554480"/>
-            <a:ext cx="3504895" cy="4572000"/>
+            <a:off x="7772400" y="1508760"/>
+            <a:ext cx="3504895" cy="4754880"/>
           </a:xfrm>
           <a:prstGeom prst="rect">
             <a:avLst/>
@@ -5878,7 +6016,7 @@
           <a:lstStyle/>
           <a:p>
             <a:pPr>
-              <a:defRPr sz="1300" b="1">
+              <a:defRPr sz="1400" b="1">
                 <a:solidFill>
                   <a:srgbClr val="0284C7"/>
                 </a:solidFill>
@@ -5895,7 +6033,7 @@
               </a:spcAft>
             </a:pPr>
             <a:r>
-              <a:rPr b="1" sz="1100">
+              <a:rPr b="1" sz="1150">
                 <a:solidFill>
                   <a:srgbClr val="0F172A"/>
                 </a:solidFill>
@@ -5904,7 +6042,7 @@
 </a:t>
             </a:r>
             <a:r>
-              <a:rPr sz="1050">
+              <a:rPr sz="1100">
                 <a:solidFill>
                   <a:srgbClr val="475569"/>
                 </a:solidFill>
@@ -5919,7 +6057,7 @@
               </a:spcAft>
             </a:pPr>
             <a:r>
-              <a:rPr b="1" sz="1100">
+              <a:rPr b="1" sz="1150">
                 <a:solidFill>
                   <a:srgbClr val="0F172A"/>
                 </a:solidFill>
@@ -5928,12 +6066,12 @@
 </a:t>
             </a:r>
             <a:r>
-              <a:rPr sz="1050">
+              <a:rPr sz="1100">
                 <a:solidFill>
                   <a:srgbClr val="475569"/>
                 </a:solidFill>
               </a:rPr>
-              <a:t>100% Match with Baseline (Credential Stuffing 174/176, Impossible Travel 75/75)</a:t>
+              <a:t>Zero performance drop on static rules (Credential Stuffing 174/176, Impossible Travel 75/75)</a:t>
             </a:r>
           </a:p>
           <a:p>
@@ -5943,7 +6081,7 @@
               </a:spcAft>
             </a:pPr>
             <a:r>
-              <a:rPr b="1" sz="1100">
+              <a:rPr b="1" sz="1150">
                 <a:solidFill>
                   <a:srgbClr val="0F172A"/>
                 </a:solidFill>
@@ -5952,12 +6090,12 @@
 </a:t>
             </a:r>
             <a:r>
-              <a:rPr sz="1050">
+              <a:rPr sz="1100">
                 <a:solidFill>
                   <a:srgbClr val="475569"/>
                 </a:solidFill>
               </a:rPr>
-              <a:t>51.95% (40/77) @ Top 2.5% Budget — 7x gain over static baseline</a:t>
+              <a:t>51.95% (40/77) @ Top 2.5% Budget — +6 extra catches over static baseline</a:t>
             </a:r>
           </a:p>
           <a:p>
@@ -5967,7 +6105,7 @@
               </a:spcAft>
             </a:pPr>
             <a:r>
-              <a:rPr b="1" sz="1100">
+              <a:rPr b="1" sz="1150">
                 <a:solidFill>
                   <a:srgbClr val="0F172A"/>
                 </a:solidFill>
@@ -5976,7 +6114,7 @@
 </a:t>
             </a:r>
             <a:r>
-              <a:rPr sz="1050">
+              <a:rPr sz="1100">
                 <a:solidFill>
                   <a:srgbClr val="475569"/>
                 </a:solidFill>
@@ -5991,7 +6129,31 @@
               </a:spcAft>
             </a:pPr>
             <a:r>
-              <a:rPr b="1" sz="1100">
+              <a:rPr b="1" sz="1150">
+                <a:solidFill>
+                  <a:srgbClr val="0F172A"/>
+                </a:solidFill>
+              </a:rPr>
+              <a:t>• Live Web Dashboard:
+</a:t>
+            </a:r>
+            <a:r>
+              <a:rPr sz="1100">
+                <a:solidFill>
+                  <a:srgbClr val="475569"/>
+                </a:solidFill>
+              </a:rPr>
+              <a:t>https://honeywell-seven.vercel.app</a:t>
+            </a:r>
+          </a:p>
+          <a:p>
+            <a:pPr>
+              <a:spcAft>
+                <a:spcPts val="1000"/>
+              </a:spcAft>
+            </a:pPr>
+            <a:r>
+              <a:rPr b="1" sz="1150">
                 <a:solidFill>
                   <a:srgbClr val="0F172A"/>
                 </a:solidFill>
@@ -6000,7 +6162,7 @@
 </a:t>
             </a:r>
             <a:r>
-              <a:rPr sz="1050">
+              <a:rPr sz="1100">
                 <a:solidFill>
                   <a:srgbClr val="475569"/>
                 </a:solidFill>
@@ -6044,7 +6206,7 @@
         </p:nvSpPr>
         <p:spPr>
           <a:xfrm>
-            <a:off x="731520" y="365760"/>
+            <a:off x="731520" y="320040"/>
             <a:ext cx="10728655" cy="822960"/>
           </a:xfrm>
           <a:prstGeom prst="rect">
@@ -6059,7 +6221,7 @@
           <a:lstStyle/>
           <a:p>
             <a:pPr>
-              <a:defRPr sz="1100" b="1">
+              <a:defRPr sz="1200" b="1">
                 <a:solidFill>
                   <a:srgbClr val="0284C7"/>
                 </a:solidFill>
@@ -6072,7 +6234,7 @@
           </a:p>
           <a:p>
             <a:pPr>
-              <a:defRPr sz="2200" b="1">
+              <a:defRPr sz="2400" b="1">
                 <a:solidFill>
                   <a:srgbClr val="0F172A"/>
                 </a:solidFill>
@@ -6093,8 +6255,8 @@
         </p:nvSpPr>
         <p:spPr>
           <a:xfrm>
-            <a:off x="731520" y="1371600"/>
-            <a:ext cx="10728655" cy="4937760"/>
+            <a:off x="731520" y="1325880"/>
+            <a:ext cx="10728655" cy="5120640"/>
           </a:xfrm>
           <a:prstGeom prst="roundRect">
             <a:avLst/>
@@ -6102,7 +6264,7 @@
           <a:solidFill>
             <a:srgbClr val="F8FAFC"/>
           </a:solidFill>
-          <a:ln w="19050">
+          <a:ln w="25400">
             <a:solidFill>
               <a:srgbClr val="0D9488"/>
             </a:solidFill>
@@ -6138,8 +6300,8 @@
         </p:nvSpPr>
         <p:spPr>
           <a:xfrm>
-            <a:off x="1005840" y="1554480"/>
-            <a:ext cx="10180015" cy="4572000"/>
+            <a:off x="1005840" y="1508760"/>
+            <a:ext cx="10180015" cy="4754880"/>
           </a:xfrm>
           <a:prstGeom prst="rect">
             <a:avLst/>
@@ -6153,7 +6315,7 @@
           <a:lstStyle/>
           <a:p>
             <a:pPr>
-              <a:defRPr sz="1400" b="1">
+              <a:defRPr sz="1500" b="1">
                 <a:solidFill>
                   <a:srgbClr val="0284C7"/>
                 </a:solidFill>
@@ -6166,11 +6328,11 @@
           <a:p>
             <a:pPr>
               <a:spcAft>
-                <a:spcPts val="1000"/>
+                <a:spcPts val="1200"/>
               </a:spcAft>
             </a:pPr>
             <a:r>
-              <a:rPr b="1" sz="1100">
+              <a:rPr b="1" sz="1200">
                 <a:solidFill>
                   <a:srgbClr val="0F172A"/>
                 </a:solidFill>
@@ -6178,7 +6340,7 @@
               <a:t>[Ref] Hochreiter, S., &amp; Schmidhuber, J. (1997). </a:t>
             </a:r>
             <a:r>
-              <a:rPr sz="1050">
+              <a:rPr sz="1100">
                 <a:solidFill>
                   <a:srgbClr val="475569"/>
                 </a:solidFill>
@@ -6189,11 +6351,11 @@
           <a:p>
             <a:pPr>
               <a:spcAft>
-                <a:spcPts val="1000"/>
+                <a:spcPts val="1200"/>
               </a:spcAft>
             </a:pPr>
             <a:r>
-              <a:rPr b="1" sz="1100">
+              <a:rPr b="1" sz="1200">
                 <a:solidFill>
                   <a:srgbClr val="0F172A"/>
                 </a:solidFill>
@@ -6201,7 +6363,7 @@
               <a:t>[Ref] Liu, F. T., Ting, K. M., &amp; Zhou, Z. H. (2008). </a:t>
             </a:r>
             <a:r>
-              <a:rPr sz="1050">
+              <a:rPr sz="1100">
                 <a:solidFill>
                   <a:srgbClr val="475569"/>
                 </a:solidFill>
@@ -6212,11 +6374,11 @@
           <a:p>
             <a:pPr>
               <a:spcAft>
-                <a:spcPts val="1000"/>
+                <a:spcPts val="1200"/>
               </a:spcAft>
             </a:pPr>
             <a:r>
-              <a:rPr b="1" sz="1100">
+              <a:rPr b="1" sz="1200">
                 <a:solidFill>
                   <a:srgbClr val="0F172A"/>
                 </a:solidFill>
@@ -6224,7 +6386,7 @@
               <a:t>[Ref] NIST Special Publication 800-94 (Rev. 1). </a:t>
             </a:r>
             <a:r>
-              <a:rPr sz="1050">
+              <a:rPr sz="1100">
                 <a:solidFill>
                   <a:srgbClr val="475569"/>
                 </a:solidFill>
@@ -6235,11 +6397,11 @@
           <a:p>
             <a:pPr>
               <a:spcAft>
-                <a:spcPts val="1000"/>
+                <a:spcPts val="1200"/>
               </a:spcAft>
             </a:pPr>
             <a:r>
-              <a:rPr b="1" sz="1100">
+              <a:rPr b="1" sz="1200">
                 <a:solidFill>
                   <a:srgbClr val="0F172A"/>
                 </a:solidFill>
@@ -6247,7 +6409,7 @@
               <a:t>[Ref] MITRE ATT&amp;CK Matrix for Enterprise (2026). </a:t>
             </a:r>
             <a:r>
-              <a:rPr sz="1050">
+              <a:rPr sz="1100">
                 <a:solidFill>
                   <a:srgbClr val="475569"/>
                 </a:solidFill>
@@ -6258,11 +6420,11 @@
           <a:p>
             <a:pPr>
               <a:spcAft>
-                <a:spcPts val="1000"/>
+                <a:spcPts val="1200"/>
               </a:spcAft>
             </a:pPr>
             <a:r>
-              <a:rPr b="1" sz="1100">
+              <a:rPr b="1" sz="1200">
                 <a:solidFill>
                   <a:srgbClr val="0F172A"/>
                 </a:solidFill>
@@ -6270,7 +6432,7 @@
               <a:t>[Ref] Honeywell Cyber Security Operations Center (2026). </a:t>
             </a:r>
             <a:r>
-              <a:rPr sz="1050">
+              <a:rPr sz="1100">
                 <a:solidFill>
                   <a:srgbClr val="475569"/>
                 </a:solidFill>

</xml_diff>

<commit_message>
feat: embed live Vercel URL at the bottom of Slide 1 metadata block
</commit_message>
<xml_diff>
--- a/docs/SentinelAI_SIH_Presentation.pptx
+++ b/docs/SentinelAI_SIH_Presentation.pptx
@@ -3109,8 +3109,8 @@
         </p:nvSpPr>
         <p:spPr>
           <a:xfrm>
-            <a:off x="731520" y="548640"/>
-            <a:ext cx="10728655" cy="5760720"/>
+            <a:off x="731520" y="457200"/>
+            <a:ext cx="10728655" cy="5943600"/>
           </a:xfrm>
           <a:prstGeom prst="roundRect">
             <a:avLst/>
@@ -3154,8 +3154,8 @@
         </p:nvSpPr>
         <p:spPr>
           <a:xfrm>
-            <a:off x="1097280" y="1005840"/>
-            <a:ext cx="9997135" cy="4846320"/>
+            <a:off x="1097280" y="731520"/>
+            <a:ext cx="9997135" cy="5394960"/>
           </a:xfrm>
           <a:prstGeom prst="rect">
             <a:avLst/>
@@ -3170,9 +3170,9 @@
           <a:p>
             <a:pPr>
               <a:spcAft>
-                <a:spcPts val="2800"/>
+                <a:spcPts val="2000"/>
               </a:spcAft>
-              <a:defRPr sz="2600" b="1">
+              <a:defRPr sz="2500" b="1">
                 <a:solidFill>
                   <a:srgbClr val="0F172A"/>
                 </a:solidFill>
@@ -3185,11 +3185,11 @@
           <a:p>
             <a:pPr>
               <a:spcAft>
-                <a:spcPts val="1000"/>
+                <a:spcPts val="800"/>
               </a:spcAft>
             </a:pPr>
             <a:r>
-              <a:rPr b="1" sz="1400">
+              <a:rPr b="1" sz="1300">
                 <a:solidFill>
                   <a:srgbClr val="D97706"/>
                 </a:solidFill>
@@ -3197,7 +3197,7 @@
               <a:t>Problem Statement ID:      </a:t>
             </a:r>
             <a:r>
-              <a:rPr b="1" sz="1400">
+              <a:rPr b="1" sz="1300">
                 <a:solidFill>
                   <a:srgbClr val="1E293B"/>
                 </a:solidFill>
@@ -3208,11 +3208,11 @@
           <a:p>
             <a:pPr>
               <a:spcAft>
-                <a:spcPts val="1000"/>
+                <a:spcPts val="800"/>
               </a:spcAft>
             </a:pPr>
             <a:r>
-              <a:rPr b="1" sz="1400">
+              <a:rPr b="1" sz="1300">
                 <a:solidFill>
                   <a:srgbClr val="D97706"/>
                 </a:solidFill>
@@ -3220,7 +3220,7 @@
               <a:t>Problem Statement Title:   </a:t>
             </a:r>
             <a:r>
-              <a:rPr b="1" sz="1400">
+              <a:rPr b="1" sz="1300">
                 <a:solidFill>
                   <a:srgbClr val="1E293B"/>
                 </a:solidFill>
@@ -3231,11 +3231,11 @@
           <a:p>
             <a:pPr>
               <a:spcAft>
-                <a:spcPts val="1000"/>
+                <a:spcPts val="800"/>
               </a:spcAft>
             </a:pPr>
             <a:r>
-              <a:rPr b="1" sz="1400">
+              <a:rPr b="1" sz="1300">
                 <a:solidFill>
                   <a:srgbClr val="D97706"/>
                 </a:solidFill>
@@ -3243,7 +3243,7 @@
               <a:t>Theme:                     </a:t>
             </a:r>
             <a:r>
-              <a:rPr b="1" sz="1400">
+              <a:rPr b="1" sz="1300">
                 <a:solidFill>
                   <a:srgbClr val="1E293B"/>
                 </a:solidFill>
@@ -3254,11 +3254,11 @@
           <a:p>
             <a:pPr>
               <a:spcAft>
-                <a:spcPts val="1000"/>
+                <a:spcPts val="800"/>
               </a:spcAft>
             </a:pPr>
             <a:r>
-              <a:rPr b="1" sz="1400">
+              <a:rPr b="1" sz="1300">
                 <a:solidFill>
                   <a:srgbClr val="D97706"/>
                 </a:solidFill>
@@ -3266,7 +3266,7 @@
               <a:t>PS Category:               </a:t>
             </a:r>
             <a:r>
-              <a:rPr b="1" sz="1400">
+              <a:rPr b="1" sz="1300">
                 <a:solidFill>
                   <a:srgbClr val="1E293B"/>
                 </a:solidFill>
@@ -3277,11 +3277,11 @@
           <a:p>
             <a:pPr>
               <a:spcAft>
-                <a:spcPts val="1000"/>
+                <a:spcPts val="800"/>
               </a:spcAft>
             </a:pPr>
             <a:r>
-              <a:rPr b="1" sz="1400">
+              <a:rPr b="1" sz="1300">
                 <a:solidFill>
                   <a:srgbClr val="D97706"/>
                 </a:solidFill>
@@ -3289,7 +3289,7 @@
               <a:t>Team Name / Lead:          </a:t>
             </a:r>
             <a:r>
-              <a:rPr b="1" sz="1400">
+              <a:rPr b="1" sz="1300">
                 <a:solidFill>
                   <a:srgbClr val="1E293B"/>
                 </a:solidFill>
@@ -3300,11 +3300,11 @@
           <a:p>
             <a:pPr>
               <a:spcAft>
-                <a:spcPts val="1000"/>
+                <a:spcPts val="800"/>
               </a:spcAft>
             </a:pPr>
             <a:r>
-              <a:rPr b="1" sz="1400">
+              <a:rPr b="1" sz="1300">
                 <a:solidFill>
                   <a:srgbClr val="D97706"/>
                 </a:solidFill>
@@ -3312,12 +3312,35 @@
               <a:t>Registration ID:           </a:t>
             </a:r>
             <a:r>
-              <a:rPr b="1" sz="1400">
+              <a:rPr b="1" sz="1300">
                 <a:solidFill>
                   <a:srgbClr val="1E293B"/>
                 </a:solidFill>
               </a:rPr>
               <a:t>23BAI10806</a:t>
+            </a:r>
+          </a:p>
+          <a:p>
+            <a:pPr>
+              <a:spcAft>
+                <a:spcPts val="800"/>
+              </a:spcAft>
+            </a:pPr>
+            <a:r>
+              <a:rPr b="1" sz="1300">
+                <a:solidFill>
+                  <a:srgbClr val="D97706"/>
+                </a:solidFill>
+              </a:rPr>
+              <a:t>Live Web Dashboard:        </a:t>
+            </a:r>
+            <a:r>
+              <a:rPr b="1" sz="1300">
+                <a:solidFill>
+                  <a:srgbClr val="0284C7"/>
+                </a:solidFill>
+              </a:rPr>
+              <a:t>https://honeywell-seven.vercel.app/</a:t>
             </a:r>
           </a:p>
         </p:txBody>
@@ -3586,15 +3609,15 @@
                   <a:srgbClr val="0F172A"/>
                 </a:solidFill>
               </a:rPr>
-              <a:t>• SOC Command Center: </a:t>
+              <a:t>• Live SOC Command Center: </a:t>
             </a:r>
             <a:r>
               <a:rPr sz="1100">
                 <a:solidFill>
-                  <a:srgbClr val="475569"/>
-                </a:solidFill>
-              </a:rPr>
-              <a:t>Interactive glassmorphic dashboard featuring live Chart.js analytics, automated incident narratives, and XAI feature attribution.</a:t>
+                  <a:srgbClr val="0284C7"/>
+                </a:solidFill>
+              </a:rPr>
+              <a:t>Interactive glassmorphic dashboard deployed live at https://honeywell-seven.vercel.app/</a:t>
             </a:r>
           </a:p>
           <a:p>
@@ -4834,15 +4857,15 @@
               </a:defRPr>
             </a:pPr>
             <a:r>
-              <a:t>Glassmorphic Web Command Center</a:t>
+              <a:t>Glassmorphic Command Center</a:t>
             </a:r>
             <a:br/>
             <a:r>
-              <a:t>Live Chart.js KPIs + Narratives</a:t>
+              <a:t>Deployed @ honeywell-seven.vercel.app</a:t>
             </a:r>
             <a:br/>
             <a:r>
-              <a:t>Interactive Feature Attribution</a:t>
+              <a:t>Chart.js KPIs + Narratives + XAI</a:t>
             </a:r>
           </a:p>
         </p:txBody>
@@ -4968,7 +4991,7 @@
                   <a:srgbClr val="475569"/>
                 </a:solidFill>
               </a:rPr>
-              <a:t>Vanilla JavaScript (ES6+), HTML5, CSS3 Glassmorphic UI, Chart.js Visual Analytics Suite</a:t>
+              <a:t>Vanilla JavaScript (ES6+), HTML5, CSS3 Glassmorphic UI, Chart.js Analytics Suite</a:t>
             </a:r>
           </a:p>
           <a:p>
@@ -4983,15 +5006,15 @@
                   <a:srgbClr val="0F172A"/>
                 </a:solidFill>
               </a:rPr>
-              <a:t>• Mathematical Hybrid Formulation: </a:t>
+              <a:t>• Live Production Deployment:      </a:t>
             </a:r>
             <a:r>
               <a:rPr sz="1150">
                 <a:solidFill>
-                  <a:srgbClr val="475569"/>
-                </a:solidFill>
-              </a:rPr>
-              <a:t>HybridScore = BaseScore if BaseScore &gt;= 3.0 else BaseScore + 0.99 * LSTM_pct (res_recent &gt;= 5)</a:t>
+                  <a:srgbClr val="0284C7"/>
+                </a:solidFill>
+              </a:rPr>
+              <a:t>Hosted live on Vercel at https://honeywell-seven.vercel.app/</a:t>
             </a:r>
           </a:p>
           <a:p>
@@ -5006,7 +5029,7 @@
                   <a:srgbClr val="0F172A"/>
                 </a:solidFill>
               </a:rPr>
-              <a:t>• Unsupervised Training Rigor:     </a:t>
+              <a:t>• Mathematical Hybrid Formulation: </a:t>
             </a:r>
             <a:r>
               <a:rPr sz="1150">
@@ -5014,7 +5037,7 @@
                   <a:srgbClr val="475569"/>
                 </a:solidFill>
               </a:rPr>
-              <a:t>Models trained exclusively on unlabeled telemetry containing ~2.5% real attacks mixed in as normal traffic.</a:t>
+              <a:t>HybridScore = BaseScore if BaseScore &gt;= 3.0 else BaseScore + 0.99 * LSTM_pct (res_recent &gt;= 5)</a:t>
             </a:r>
           </a:p>
         </p:txBody>
@@ -6073,10 +6096,10 @@
             <a:r>
               <a:rPr sz="1100">
                 <a:solidFill>
-                  <a:srgbClr val="475569"/>
-                </a:solidFill>
-              </a:rPr>
-              <a:t>https://honeywell-seven.vercel.app</a:t>
+                  <a:srgbClr val="0284C7"/>
+                </a:solidFill>
+              </a:rPr>
+              <a:t>https://honeywell-seven.vercel.app/</a:t>
             </a:r>
           </a:p>
           <a:p>

</xml_diff>